<commit_message>
Updates course website with answers to functions lecture.
Signed-off-by: Charlie Murphy <tcm3@cs.princeton.edu>
</commit_message>
<xml_diff>
--- a/courses/csci246/spring26/slides/03_06_26_functions.pptx
+++ b/courses/csci246/spring26/slides/03_06_26_functions.pptx
@@ -226,7 +226,7 @@
           <a:p>
             <a:fld id="{B7930911-D214-D045-9349-C37725674895}" type="datetimeFigureOut">
               <a:rPr lang="en-US" smtClean="0"/>
-              <a:t>3/5/2026</a:t>
+              <a:t>3/6/26</a:t>
             </a:fld>
             <a:endParaRPr lang="en-US"/>
           </a:p>
@@ -640,7 +640,7 @@
           <a:p>
             <a:fld id="{05900130-2E42-9F4E-B9EA-739EF1E7DBD9}" type="datetimeFigureOut">
               <a:rPr lang="en-US" smtClean="0"/>
-              <a:t>3/5/2026</a:t>
+              <a:t>3/6/26</a:t>
             </a:fld>
             <a:endParaRPr lang="en-US"/>
           </a:p>
@@ -838,7 +838,7 @@
           <a:p>
             <a:fld id="{05900130-2E42-9F4E-B9EA-739EF1E7DBD9}" type="datetimeFigureOut">
               <a:rPr lang="en-US" smtClean="0"/>
-              <a:t>3/5/2026</a:t>
+              <a:t>3/6/26</a:t>
             </a:fld>
             <a:endParaRPr lang="en-US"/>
           </a:p>
@@ -1046,7 +1046,7 @@
           <a:p>
             <a:fld id="{05900130-2E42-9F4E-B9EA-739EF1E7DBD9}" type="datetimeFigureOut">
               <a:rPr lang="en-US" smtClean="0"/>
-              <a:t>3/5/2026</a:t>
+              <a:t>3/6/26</a:t>
             </a:fld>
             <a:endParaRPr lang="en-US"/>
           </a:p>
@@ -1244,7 +1244,7 @@
           <a:p>
             <a:fld id="{05900130-2E42-9F4E-B9EA-739EF1E7DBD9}" type="datetimeFigureOut">
               <a:rPr lang="en-US" smtClean="0"/>
-              <a:t>3/5/2026</a:t>
+              <a:t>3/6/26</a:t>
             </a:fld>
             <a:endParaRPr lang="en-US"/>
           </a:p>
@@ -1519,7 +1519,7 @@
           <a:p>
             <a:fld id="{05900130-2E42-9F4E-B9EA-739EF1E7DBD9}" type="datetimeFigureOut">
               <a:rPr lang="en-US" smtClean="0"/>
-              <a:t>3/5/2026</a:t>
+              <a:t>3/6/26</a:t>
             </a:fld>
             <a:endParaRPr lang="en-US"/>
           </a:p>
@@ -1784,7 +1784,7 @@
           <a:p>
             <a:fld id="{05900130-2E42-9F4E-B9EA-739EF1E7DBD9}" type="datetimeFigureOut">
               <a:rPr lang="en-US" smtClean="0"/>
-              <a:t>3/5/2026</a:t>
+              <a:t>3/6/26</a:t>
             </a:fld>
             <a:endParaRPr lang="en-US"/>
           </a:p>
@@ -2196,7 +2196,7 @@
           <a:p>
             <a:fld id="{05900130-2E42-9F4E-B9EA-739EF1E7DBD9}" type="datetimeFigureOut">
               <a:rPr lang="en-US" smtClean="0"/>
-              <a:t>3/5/2026</a:t>
+              <a:t>3/6/26</a:t>
             </a:fld>
             <a:endParaRPr lang="en-US"/>
           </a:p>
@@ -2337,7 +2337,7 @@
           <a:p>
             <a:fld id="{05900130-2E42-9F4E-B9EA-739EF1E7DBD9}" type="datetimeFigureOut">
               <a:rPr lang="en-US" smtClean="0"/>
-              <a:t>3/5/2026</a:t>
+              <a:t>3/6/26</a:t>
             </a:fld>
             <a:endParaRPr lang="en-US"/>
           </a:p>
@@ -2450,7 +2450,7 @@
           <a:p>
             <a:fld id="{05900130-2E42-9F4E-B9EA-739EF1E7DBD9}" type="datetimeFigureOut">
               <a:rPr lang="en-US" smtClean="0"/>
-              <a:t>3/5/2026</a:t>
+              <a:t>3/6/26</a:t>
             </a:fld>
             <a:endParaRPr lang="en-US"/>
           </a:p>
@@ -2761,7 +2761,7 @@
           <a:p>
             <a:fld id="{05900130-2E42-9F4E-B9EA-739EF1E7DBD9}" type="datetimeFigureOut">
               <a:rPr lang="en-US" smtClean="0"/>
-              <a:t>3/5/2026</a:t>
+              <a:t>3/6/26</a:t>
             </a:fld>
             <a:endParaRPr lang="en-US"/>
           </a:p>
@@ -3049,7 +3049,7 @@
           <a:p>
             <a:fld id="{05900130-2E42-9F4E-B9EA-739EF1E7DBD9}" type="datetimeFigureOut">
               <a:rPr lang="en-US" smtClean="0"/>
-              <a:t>3/5/2026</a:t>
+              <a:t>3/6/26</a:t>
             </a:fld>
             <a:endParaRPr lang="en-US"/>
           </a:p>
@@ -3290,7 +3290,7 @@
           <a:p>
             <a:fld id="{05900130-2E42-9F4E-B9EA-739EF1E7DBD9}" type="datetimeFigureOut">
               <a:rPr lang="en-US" smtClean="0"/>
-              <a:t>3/5/2026</a:t>
+              <a:t>3/6/26</a:t>
             </a:fld>
             <a:endParaRPr lang="en-US"/>
           </a:p>
@@ -4298,8 +4298,8 @@
             </a:p>
           </p:txBody>
         </p:sp>
-        <mc:AlternateContent xmlns:mc="http://schemas.openxmlformats.org/markup-compatibility/2006">
-          <mc:Choice xmlns:a14="http://schemas.microsoft.com/office/drawing/2010/main" Requires="a14">
+        <mc:AlternateContent xmlns:mc="http://schemas.openxmlformats.org/markup-compatibility/2006" xmlns:a14="http://schemas.microsoft.com/office/drawing/2010/main">
+          <mc:Choice Requires="a14">
             <p:sp>
               <p:nvSpPr>
                 <p:cNvPr id="6" name="TextBox 5">
@@ -4328,6 +4328,7 @@
                 </a:bodyPr>
                 <a:lstStyle/>
                 <a:p>
+                  <a:pPr/>
                   <a14:m>
                     <m:oMathPara xmlns:m="http://schemas.openxmlformats.org/officeDocument/2006/math">
                       <m:oMathParaPr>
@@ -4352,7 +4353,7 @@
               </p:txBody>
             </p:sp>
           </mc:Choice>
-          <mc:Fallback>
+          <mc:Fallback xmlns="">
             <p:sp>
               <p:nvSpPr>
                 <p:cNvPr id="6" name="TextBox 5">
@@ -4527,8 +4528,8 @@
             </a:p>
           </p:txBody>
         </p:sp>
-        <mc:AlternateContent xmlns:mc="http://schemas.openxmlformats.org/markup-compatibility/2006">
-          <mc:Choice xmlns:a14="http://schemas.microsoft.com/office/drawing/2010/main" Requires="a14">
+        <mc:AlternateContent xmlns:mc="http://schemas.openxmlformats.org/markup-compatibility/2006" xmlns:a14="http://schemas.microsoft.com/office/drawing/2010/main">
+          <mc:Choice Requires="a14">
             <p:sp>
               <p:nvSpPr>
                 <p:cNvPr id="9" name="TextBox 8">
@@ -4557,6 +4558,7 @@
                 </a:bodyPr>
                 <a:lstStyle/>
                 <a:p>
+                  <a:pPr/>
                   <a14:m>
                     <m:oMathPara xmlns:m="http://schemas.openxmlformats.org/officeDocument/2006/math">
                       <m:oMathParaPr>
@@ -4581,7 +4583,7 @@
               </p:txBody>
             </p:sp>
           </mc:Choice>
-          <mc:Fallback>
+          <mc:Fallback xmlns="">
             <p:sp>
               <p:nvSpPr>
                 <p:cNvPr id="9" name="TextBox 8">
@@ -4626,8 +4628,8 @@
             </p:sp>
           </mc:Fallback>
         </mc:AlternateContent>
-        <mc:AlternateContent xmlns:mc="http://schemas.openxmlformats.org/markup-compatibility/2006">
-          <mc:Choice xmlns:a14="http://schemas.microsoft.com/office/drawing/2010/main" Requires="a14">
+        <mc:AlternateContent xmlns:mc="http://schemas.openxmlformats.org/markup-compatibility/2006" xmlns:a14="http://schemas.microsoft.com/office/drawing/2010/main">
+          <mc:Choice Requires="a14">
             <p:sp>
               <p:nvSpPr>
                 <p:cNvPr id="11" name="TextBox 10">
@@ -4656,6 +4658,7 @@
                 </a:bodyPr>
                 <a:lstStyle/>
                 <a:p>
+                  <a:pPr/>
                   <a14:m>
                     <m:oMathPara xmlns:m="http://schemas.openxmlformats.org/officeDocument/2006/math">
                       <m:oMathParaPr>
@@ -4680,7 +4683,7 @@
               </p:txBody>
             </p:sp>
           </mc:Choice>
-          <mc:Fallback>
+          <mc:Fallback xmlns="">
             <p:sp>
               <p:nvSpPr>
                 <p:cNvPr id="11" name="TextBox 10">
@@ -7056,7 +7059,7 @@
                         <a:latin typeface="Cambria Math" panose="02040503050406030204" pitchFamily="18" charset="0"/>
                         <a:cs typeface="Arial" panose="020B0604020202020204" pitchFamily="34" charset="0"/>
                       </a:rPr>
-                      <m:t>𝐵</m:t>
+                      <m:t>𝑓</m:t>
                     </m:r>
                   </m:oMath>
                 </a14:m>
@@ -7096,7 +7099,7 @@
               <a:blipFill>
                 <a:blip r:embed="rId2"/>
                 <a:stretch>
-                  <a:fillRect l="-1217" t="-3602" r="-870" b="-2754"/>
+                  <a:fillRect l="-1206" t="-3509" r="-965" b="-2632"/>
                 </a:stretch>
               </a:blipFill>
             </p:spPr>
@@ -8714,8 +8717,8 @@
           </a:p>
         </p:txBody>
       </p:sp>
-      <mc:AlternateContent xmlns:mc="http://schemas.openxmlformats.org/markup-compatibility/2006">
-        <mc:Choice xmlns:a14="http://schemas.microsoft.com/office/drawing/2010/main" Requires="a14">
+      <mc:AlternateContent xmlns:mc="http://schemas.openxmlformats.org/markup-compatibility/2006" xmlns:a14="http://schemas.microsoft.com/office/drawing/2010/main">
+        <mc:Choice Requires="a14">
           <p:sp>
             <p:nvSpPr>
               <p:cNvPr id="3" name="Content Placeholder 14">
@@ -9076,7 +9079,7 @@
             </p:txBody>
           </p:sp>
         </mc:Choice>
-        <mc:Fallback>
+        <mc:Fallback xmlns="">
           <p:sp>
             <p:nvSpPr>
               <p:cNvPr id="3" name="Content Placeholder 14">
@@ -10345,8 +10348,8 @@
           </a:p>
         </p:txBody>
       </p:sp>
-      <mc:AlternateContent xmlns:mc="http://schemas.openxmlformats.org/markup-compatibility/2006">
-        <mc:Choice xmlns:a14="http://schemas.microsoft.com/office/drawing/2010/main" Requires="a14">
+      <mc:AlternateContent xmlns:mc="http://schemas.openxmlformats.org/markup-compatibility/2006" xmlns:a14="http://schemas.microsoft.com/office/drawing/2010/main">
+        <mc:Choice Requires="a14">
           <p:sp>
             <p:nvSpPr>
               <p:cNvPr id="4" name="Content Placeholder 14">
@@ -10542,7 +10545,7 @@
             </p:txBody>
           </p:sp>
         </mc:Choice>
-        <mc:Fallback>
+        <mc:Fallback xmlns="">
           <p:sp>
             <p:nvSpPr>
               <p:cNvPr id="4" name="Content Placeholder 14">
@@ -10736,8 +10739,8 @@
             </a:p>
           </p:txBody>
         </p:sp>
-        <mc:AlternateContent xmlns:mc="http://schemas.openxmlformats.org/markup-compatibility/2006">
-          <mc:Choice xmlns:a14="http://schemas.microsoft.com/office/drawing/2010/main" Requires="a14">
+        <mc:AlternateContent xmlns:mc="http://schemas.openxmlformats.org/markup-compatibility/2006" xmlns:a14="http://schemas.microsoft.com/office/drawing/2010/main">
+          <mc:Choice Requires="a14">
             <p:sp>
               <p:nvSpPr>
                 <p:cNvPr id="8" name="TextBox 7">
@@ -10766,6 +10769,7 @@
                 </a:bodyPr>
                 <a:lstStyle/>
                 <a:p>
+                  <a:pPr/>
                   <a14:m>
                     <m:oMathPara xmlns:m="http://schemas.openxmlformats.org/officeDocument/2006/math">
                       <m:oMathParaPr>
@@ -10790,7 +10794,7 @@
               </p:txBody>
             </p:sp>
           </mc:Choice>
-          <mc:Fallback>
+          <mc:Fallback xmlns="">
             <p:sp>
               <p:nvSpPr>
                 <p:cNvPr id="8" name="TextBox 7">
@@ -10965,8 +10969,8 @@
             </a:p>
           </p:txBody>
         </p:sp>
-        <mc:AlternateContent xmlns:mc="http://schemas.openxmlformats.org/markup-compatibility/2006">
-          <mc:Choice xmlns:a14="http://schemas.microsoft.com/office/drawing/2010/main" Requires="a14">
+        <mc:AlternateContent xmlns:mc="http://schemas.openxmlformats.org/markup-compatibility/2006" xmlns:a14="http://schemas.microsoft.com/office/drawing/2010/main">
+          <mc:Choice Requires="a14">
             <p:sp>
               <p:nvSpPr>
                 <p:cNvPr id="11" name="TextBox 10">
@@ -10995,6 +10999,7 @@
                 </a:bodyPr>
                 <a:lstStyle/>
                 <a:p>
+                  <a:pPr/>
                   <a14:m>
                     <m:oMathPara xmlns:m="http://schemas.openxmlformats.org/officeDocument/2006/math">
                       <m:oMathParaPr>
@@ -11019,7 +11024,7 @@
               </p:txBody>
             </p:sp>
           </mc:Choice>
-          <mc:Fallback>
+          <mc:Fallback xmlns="">
             <p:sp>
               <p:nvSpPr>
                 <p:cNvPr id="11" name="TextBox 10">
@@ -11064,8 +11069,8 @@
             </p:sp>
           </mc:Fallback>
         </mc:AlternateContent>
-        <mc:AlternateContent xmlns:mc="http://schemas.openxmlformats.org/markup-compatibility/2006">
-          <mc:Choice xmlns:a14="http://schemas.microsoft.com/office/drawing/2010/main" Requires="a14">
+        <mc:AlternateContent xmlns:mc="http://schemas.openxmlformats.org/markup-compatibility/2006" xmlns:a14="http://schemas.microsoft.com/office/drawing/2010/main">
+          <mc:Choice Requires="a14">
             <p:sp>
               <p:nvSpPr>
                 <p:cNvPr id="12" name="TextBox 11">
@@ -11094,6 +11099,7 @@
                 </a:bodyPr>
                 <a:lstStyle/>
                 <a:p>
+                  <a:pPr/>
                   <a14:m>
                     <m:oMathPara xmlns:m="http://schemas.openxmlformats.org/officeDocument/2006/math">
                       <m:oMathParaPr>
@@ -11118,7 +11124,7 @@
               </p:txBody>
             </p:sp>
           </mc:Choice>
-          <mc:Fallback>
+          <mc:Fallback xmlns="">
             <p:sp>
               <p:nvSpPr>
                 <p:cNvPr id="12" name="TextBox 11">
@@ -11622,8 +11628,8 @@
             </a:p>
           </p:txBody>
         </p:sp>
-        <mc:AlternateContent xmlns:mc="http://schemas.openxmlformats.org/markup-compatibility/2006">
-          <mc:Choice xmlns:a14="http://schemas.microsoft.com/office/drawing/2010/main" Requires="a14">
+        <mc:AlternateContent xmlns:mc="http://schemas.openxmlformats.org/markup-compatibility/2006" xmlns:a14="http://schemas.microsoft.com/office/drawing/2010/main">
+          <mc:Choice Requires="a14">
             <p:sp>
               <p:nvSpPr>
                 <p:cNvPr id="35" name="TextBox 34">
@@ -11652,6 +11658,7 @@
                 </a:bodyPr>
                 <a:lstStyle/>
                 <a:p>
+                  <a:pPr/>
                   <a14:m>
                     <m:oMathPara xmlns:m="http://schemas.openxmlformats.org/officeDocument/2006/math">
                       <m:oMathParaPr>
@@ -11676,7 +11683,7 @@
               </p:txBody>
             </p:sp>
           </mc:Choice>
-          <mc:Fallback>
+          <mc:Fallback xmlns="">
             <p:sp>
               <p:nvSpPr>
                 <p:cNvPr id="35" name="TextBox 34">
@@ -11851,8 +11858,8 @@
             </a:p>
           </p:txBody>
         </p:sp>
-        <mc:AlternateContent xmlns:mc="http://schemas.openxmlformats.org/markup-compatibility/2006">
-          <mc:Choice xmlns:a14="http://schemas.microsoft.com/office/drawing/2010/main" Requires="a14">
+        <mc:AlternateContent xmlns:mc="http://schemas.openxmlformats.org/markup-compatibility/2006" xmlns:a14="http://schemas.microsoft.com/office/drawing/2010/main">
+          <mc:Choice Requires="a14">
             <p:sp>
               <p:nvSpPr>
                 <p:cNvPr id="38" name="TextBox 37">
@@ -11881,6 +11888,7 @@
                 </a:bodyPr>
                 <a:lstStyle/>
                 <a:p>
+                  <a:pPr/>
                   <a14:m>
                     <m:oMathPara xmlns:m="http://schemas.openxmlformats.org/officeDocument/2006/math">
                       <m:oMathParaPr>
@@ -11905,7 +11913,7 @@
               </p:txBody>
             </p:sp>
           </mc:Choice>
-          <mc:Fallback>
+          <mc:Fallback xmlns="">
             <p:sp>
               <p:nvSpPr>
                 <p:cNvPr id="38" name="TextBox 37">
@@ -11950,8 +11958,8 @@
             </p:sp>
           </mc:Fallback>
         </mc:AlternateContent>
-        <mc:AlternateContent xmlns:mc="http://schemas.openxmlformats.org/markup-compatibility/2006">
-          <mc:Choice xmlns:a14="http://schemas.microsoft.com/office/drawing/2010/main" Requires="a14">
+        <mc:AlternateContent xmlns:mc="http://schemas.openxmlformats.org/markup-compatibility/2006" xmlns:a14="http://schemas.microsoft.com/office/drawing/2010/main">
+          <mc:Choice Requires="a14">
             <p:sp>
               <p:nvSpPr>
                 <p:cNvPr id="39" name="TextBox 38">
@@ -11980,6 +11988,7 @@
                 </a:bodyPr>
                 <a:lstStyle/>
                 <a:p>
+                  <a:pPr/>
                   <a14:m>
                     <m:oMathPara xmlns:m="http://schemas.openxmlformats.org/officeDocument/2006/math">
                       <m:oMathParaPr>
@@ -12004,7 +12013,7 @@
               </p:txBody>
             </p:sp>
           </mc:Choice>
-          <mc:Fallback>
+          <mc:Fallback xmlns="">
             <p:sp>
               <p:nvSpPr>
                 <p:cNvPr id="39" name="TextBox 38">
@@ -12934,8 +12943,8 @@
           </a:p>
         </p:txBody>
       </p:sp>
-      <mc:AlternateContent xmlns:mc="http://schemas.openxmlformats.org/markup-compatibility/2006">
-        <mc:Choice xmlns:a14="http://schemas.microsoft.com/office/drawing/2010/main" Requires="a14">
+      <mc:AlternateContent xmlns:mc="http://schemas.openxmlformats.org/markup-compatibility/2006" xmlns:a14="http://schemas.microsoft.com/office/drawing/2010/main">
+        <mc:Choice Requires="a14">
           <p:sp>
             <p:nvSpPr>
               <p:cNvPr id="4" name="Content Placeholder 14">
@@ -13550,7 +13559,7 @@
             </p:txBody>
           </p:sp>
         </mc:Choice>
-        <mc:Fallback>
+        <mc:Fallback xmlns="">
           <p:sp>
             <p:nvSpPr>
               <p:cNvPr id="4" name="Content Placeholder 14">
@@ -14222,8 +14231,8 @@
             </a:p>
           </p:txBody>
         </p:sp>
-        <mc:AlternateContent xmlns:mc="http://schemas.openxmlformats.org/markup-compatibility/2006">
-          <mc:Choice xmlns:a14="http://schemas.microsoft.com/office/drawing/2010/main" Requires="a14">
+        <mc:AlternateContent xmlns:mc="http://schemas.openxmlformats.org/markup-compatibility/2006" xmlns:a14="http://schemas.microsoft.com/office/drawing/2010/main">
+          <mc:Choice Requires="a14">
             <p:sp>
               <p:nvSpPr>
                 <p:cNvPr id="7" name="TextBox 6">
@@ -14252,6 +14261,7 @@
                 </a:bodyPr>
                 <a:lstStyle/>
                 <a:p>
+                  <a:pPr/>
                   <a14:m>
                     <m:oMathPara xmlns:m="http://schemas.openxmlformats.org/officeDocument/2006/math">
                       <m:oMathParaPr>
@@ -14276,7 +14286,7 @@
               </p:txBody>
             </p:sp>
           </mc:Choice>
-          <mc:Fallback>
+          <mc:Fallback xmlns="">
             <p:sp>
               <p:nvSpPr>
                 <p:cNvPr id="7" name="TextBox 6">
@@ -14451,8 +14461,8 @@
             </a:p>
           </p:txBody>
         </p:sp>
-        <mc:AlternateContent xmlns:mc="http://schemas.openxmlformats.org/markup-compatibility/2006">
-          <mc:Choice xmlns:a14="http://schemas.microsoft.com/office/drawing/2010/main" Requires="a14">
+        <mc:AlternateContent xmlns:mc="http://schemas.openxmlformats.org/markup-compatibility/2006" xmlns:a14="http://schemas.microsoft.com/office/drawing/2010/main">
+          <mc:Choice Requires="a14">
             <p:sp>
               <p:nvSpPr>
                 <p:cNvPr id="10" name="TextBox 9">
@@ -14481,6 +14491,7 @@
                 </a:bodyPr>
                 <a:lstStyle/>
                 <a:p>
+                  <a:pPr/>
                   <a14:m>
                     <m:oMathPara xmlns:m="http://schemas.openxmlformats.org/officeDocument/2006/math">
                       <m:oMathParaPr>
@@ -14505,7 +14516,7 @@
               </p:txBody>
             </p:sp>
           </mc:Choice>
-          <mc:Fallback>
+          <mc:Fallback xmlns="">
             <p:sp>
               <p:nvSpPr>
                 <p:cNvPr id="10" name="TextBox 9">
@@ -14550,8 +14561,8 @@
             </p:sp>
           </mc:Fallback>
         </mc:AlternateContent>
-        <mc:AlternateContent xmlns:mc="http://schemas.openxmlformats.org/markup-compatibility/2006">
-          <mc:Choice xmlns:a14="http://schemas.microsoft.com/office/drawing/2010/main" Requires="a14">
+        <mc:AlternateContent xmlns:mc="http://schemas.openxmlformats.org/markup-compatibility/2006" xmlns:a14="http://schemas.microsoft.com/office/drawing/2010/main">
+          <mc:Choice Requires="a14">
             <p:sp>
               <p:nvSpPr>
                 <p:cNvPr id="11" name="TextBox 10">
@@ -14580,6 +14591,7 @@
                 </a:bodyPr>
                 <a:lstStyle/>
                 <a:p>
+                  <a:pPr/>
                   <a14:m>
                     <m:oMathPara xmlns:m="http://schemas.openxmlformats.org/officeDocument/2006/math">
                       <m:oMathParaPr>
@@ -14604,7 +14616,7 @@
               </p:txBody>
             </p:sp>
           </mc:Choice>
-          <mc:Fallback>
+          <mc:Fallback xmlns="">
             <p:sp>
               <p:nvSpPr>
                 <p:cNvPr id="11" name="TextBox 10">
@@ -15108,8 +15120,8 @@
             </a:p>
           </p:txBody>
         </p:sp>
-        <mc:AlternateContent xmlns:mc="http://schemas.openxmlformats.org/markup-compatibility/2006">
-          <mc:Choice xmlns:a14="http://schemas.microsoft.com/office/drawing/2010/main" Requires="a14">
+        <mc:AlternateContent xmlns:mc="http://schemas.openxmlformats.org/markup-compatibility/2006" xmlns:a14="http://schemas.microsoft.com/office/drawing/2010/main">
+          <mc:Choice Requires="a14">
             <p:sp>
               <p:nvSpPr>
                 <p:cNvPr id="22" name="TextBox 21">
@@ -15138,6 +15150,7 @@
                 </a:bodyPr>
                 <a:lstStyle/>
                 <a:p>
+                  <a:pPr/>
                   <a14:m>
                     <m:oMathPara xmlns:m="http://schemas.openxmlformats.org/officeDocument/2006/math">
                       <m:oMathParaPr>
@@ -15162,7 +15175,7 @@
               </p:txBody>
             </p:sp>
           </mc:Choice>
-          <mc:Fallback>
+          <mc:Fallback xmlns="">
             <p:sp>
               <p:nvSpPr>
                 <p:cNvPr id="22" name="TextBox 21">
@@ -15337,8 +15350,8 @@
             </a:p>
           </p:txBody>
         </p:sp>
-        <mc:AlternateContent xmlns:mc="http://schemas.openxmlformats.org/markup-compatibility/2006">
-          <mc:Choice xmlns:a14="http://schemas.microsoft.com/office/drawing/2010/main" Requires="a14">
+        <mc:AlternateContent xmlns:mc="http://schemas.openxmlformats.org/markup-compatibility/2006" xmlns:a14="http://schemas.microsoft.com/office/drawing/2010/main">
+          <mc:Choice Requires="a14">
             <p:sp>
               <p:nvSpPr>
                 <p:cNvPr id="25" name="TextBox 24">
@@ -15367,6 +15380,7 @@
                 </a:bodyPr>
                 <a:lstStyle/>
                 <a:p>
+                  <a:pPr/>
                   <a14:m>
                     <m:oMathPara xmlns:m="http://schemas.openxmlformats.org/officeDocument/2006/math">
                       <m:oMathParaPr>
@@ -15391,7 +15405,7 @@
               </p:txBody>
             </p:sp>
           </mc:Choice>
-          <mc:Fallback>
+          <mc:Fallback xmlns="">
             <p:sp>
               <p:nvSpPr>
                 <p:cNvPr id="25" name="TextBox 24">
@@ -15436,8 +15450,8 @@
             </p:sp>
           </mc:Fallback>
         </mc:AlternateContent>
-        <mc:AlternateContent xmlns:mc="http://schemas.openxmlformats.org/markup-compatibility/2006">
-          <mc:Choice xmlns:a14="http://schemas.microsoft.com/office/drawing/2010/main" Requires="a14">
+        <mc:AlternateContent xmlns:mc="http://schemas.openxmlformats.org/markup-compatibility/2006" xmlns:a14="http://schemas.microsoft.com/office/drawing/2010/main">
+          <mc:Choice Requires="a14">
             <p:sp>
               <p:nvSpPr>
                 <p:cNvPr id="26" name="TextBox 25">
@@ -15466,6 +15480,7 @@
                 </a:bodyPr>
                 <a:lstStyle/>
                 <a:p>
+                  <a:pPr/>
                   <a14:m>
                     <m:oMathPara xmlns:m="http://schemas.openxmlformats.org/officeDocument/2006/math">
                       <m:oMathParaPr>
@@ -15490,7 +15505,7 @@
               </p:txBody>
             </p:sp>
           </mc:Choice>
-          <mc:Fallback>
+          <mc:Fallback xmlns="">
             <p:sp>
               <p:nvSpPr>
                 <p:cNvPr id="26" name="TextBox 25">

</xml_diff>